<commit_message>
Business case: brief solution box on slide 1, Current State cut to four
Slide 1 now carries a short Proposed Solution / Model box, as the
edited one-pager had, with "Detail on slide 2" set against the heading
so the reader knows where the rest is. Four lines: what you upload,
what comes back, the scale, and the tools by name.

Current State is down from seven points to four. Two of them were
merged (engineers' time and scaling) and one dropped.

Problem Statement gave up the height for the new box; body text went
from 10.5pt to 10pt, which is still well above the 7.8pt the crowded
single slide had been running at.

Verified: validate.py passes, two slides, every text block inside its
box with 0.05-0.52in of margin, and no reference to the other
proposal's subject matter.

Co-Authored-By: Claude Opus 5 <noreply@anthropic.com>
Claude-Session: https://claude.ai/code/session_019qdUjZ8WZYLU54FEixJk1i
</commit_message>
<xml_diff>
--- a/BrainSpark_Business_Case.pptx
+++ b/BrainSpark_Business_Case.pptx
@@ -1051,11 +1051,11 @@
         <p:spPr>
           <a:xfrm>
             <a:off x="457200" y="960120"/>
-            <a:ext cx="6812280" cy="2651760"/>
+            <a:ext cx="6812280" cy="2304288"/>
           </a:xfrm>
           <a:prstGeom prst="roundRect">
             <a:avLst>
-              <a:gd name="adj" fmla="val 3103"/>
+              <a:gd name="adj" fmla="val 3571"/>
             </a:avLst>
           </a:prstGeom>
           <a:solidFill>
@@ -1180,8 +1180,8 @@
         </p:nvSpPr>
         <p:spPr>
           <a:xfrm>
-            <a:off x="694944" y="1408176"/>
-            <a:ext cx="6336792" cy="2029968"/>
+            <a:off x="694944" y="1371600"/>
+            <a:ext cx="6336792" cy="1737360"/>
           </a:xfrm>
           <a:prstGeom prst="rect">
             <a:avLst/>
@@ -1198,13 +1198,13 @@
                 <a:spcPct val="93000"/>
               </a:lnSpc>
               <a:spcAft>
-                <a:spcPts val="1000"/>
+                <a:spcPts val="900"/>
               </a:spcAft>
               <a:buSzPct val="100000"/>
               <a:buChar char="•"/>
             </a:pPr>
             <a:r>
-              <a:rPr lang="en-US" sz="1050" dirty="0">
+              <a:rPr lang="en-US" sz="1000" dirty="0">
                 <a:solidFill>
                   <a:srgbClr val="1F2328"/>
                 </a:solidFill>
@@ -1214,7 +1214,7 @@
               </a:rPr>
               <a:t>Cost reduction ideas are usually generated through workshops. Setting these up can take weeks, and the quality of the output depends on which cross-functional team members attend.</a:t>
             </a:r>
-            <a:endParaRPr lang="en-US" sz="1050" dirty="0"/>
+            <a:endParaRPr lang="en-US" sz="1000" dirty="0"/>
           </a:p>
           <a:p>
             <a:pPr marL="342900" indent="-342900">
@@ -1222,13 +1222,13 @@
                 <a:spcPct val="93000"/>
               </a:lnSpc>
               <a:spcAft>
-                <a:spcPts val="1000"/>
+                <a:spcPts val="900"/>
               </a:spcAft>
               <a:buSzPct val="100000"/>
               <a:buChar char="•"/>
             </a:pPr>
             <a:r>
-              <a:rPr lang="en-US" sz="1050" dirty="0">
+              <a:rPr lang="en-US" sz="1000" dirty="0">
                 <a:solidFill>
                   <a:srgbClr val="1F2328"/>
                 </a:solidFill>
@@ -1238,7 +1238,7 @@
               </a:rPr>
               <a:t>Most ideas are captured as a single line, such as "change the material" or "remove the bracket", with little detail on the process, material grade, tolerances or quantities involved.</a:t>
             </a:r>
-            <a:endParaRPr lang="en-US" sz="1050" dirty="0"/>
+            <a:endParaRPr lang="en-US" sz="1000" dirty="0"/>
           </a:p>
           <a:p>
             <a:pPr marL="342900" indent="-342900">
@@ -1246,13 +1246,13 @@
                 <a:spcPct val="93000"/>
               </a:lnSpc>
               <a:spcAft>
-                <a:spcPts val="1000"/>
+                <a:spcPts val="900"/>
               </a:spcAft>
               <a:buSzPct val="100000"/>
               <a:buChar char="•"/>
             </a:pPr>
             <a:r>
-              <a:rPr lang="en-US" sz="1050" dirty="0">
+              <a:rPr lang="en-US" sz="1000" dirty="0">
                 <a:solidFill>
                   <a:srgbClr val="1F2328"/>
                 </a:solidFill>
@@ -1262,7 +1262,7 @@
               </a:rPr>
               <a:t>Nobody knows whether an idea is worth 20p or £2 until someone manually evaluates and costs it.</a:t>
             </a:r>
-            <a:endParaRPr lang="en-US" sz="1050" dirty="0"/>
+            <a:endParaRPr lang="en-US" sz="1000" dirty="0"/>
           </a:p>
           <a:p>
             <a:pPr marL="342900" indent="-342900">
@@ -1270,13 +1270,13 @@
                 <a:spcPct val="93000"/>
               </a:lnSpc>
               <a:spcAft>
-                <a:spcPts val="1000"/>
+                <a:spcPts val="900"/>
               </a:spcAft>
               <a:buSzPct val="100000"/>
               <a:buChar char="•"/>
             </a:pPr>
             <a:r>
-              <a:rPr lang="en-US" sz="1050" dirty="0">
+              <a:rPr lang="en-US" sz="1000" dirty="0">
                 <a:solidFill>
                   <a:srgbClr val="1F2328"/>
                 </a:solidFill>
@@ -1286,7 +1286,7 @@
               </a:rPr>
               <a:t>A programme can contain thousands of parts, but workshops typically review only a small number, so many commodities and opportunities are never explored.</a:t>
             </a:r>
-            <a:endParaRPr lang="en-US" sz="1050" dirty="0"/>
+            <a:endParaRPr lang="en-US" sz="1000" dirty="0"/>
           </a:p>
           <a:p>
             <a:pPr marL="342900" indent="-342900">
@@ -1294,13 +1294,13 @@
                 <a:spcPct val="93000"/>
               </a:lnSpc>
               <a:spcAft>
-                <a:spcPts val="1000"/>
+                <a:spcPts val="900"/>
               </a:spcAft>
               <a:buSzPct val="100000"/>
               <a:buChar char="•"/>
             </a:pPr>
             <a:r>
-              <a:rPr lang="en-US" sz="1050" dirty="0">
+              <a:rPr lang="en-US" sz="1000" dirty="0">
                 <a:solidFill>
                   <a:srgbClr val="1F2328"/>
                 </a:solidFill>
@@ -1310,7 +1310,7 @@
               </a:rPr>
               <a:t>Opportunities often depend on individual expertise. If the right knowledge is not in the room at the time, valuable ideas are overlooked.</a:t>
             </a:r>
-            <a:endParaRPr lang="en-US" sz="1050" dirty="0"/>
+            <a:endParaRPr lang="en-US" sz="1000" dirty="0"/>
           </a:p>
         </p:txBody>
       </p:sp>
@@ -1322,12 +1322,12 @@
         </p:nvSpPr>
         <p:spPr>
           <a:xfrm>
-            <a:off x="457200" y="3721608"/>
-            <a:ext cx="6812280" cy="2907792"/>
+            <a:off x="457200" y="3328416"/>
+            <a:ext cx="6812280" cy="1581912"/>
           </a:xfrm>
           <a:prstGeom prst="roundRect">
             <a:avLst>
-              <a:gd name="adj" fmla="val 2830"/>
+              <a:gd name="adj" fmla="val 5202"/>
             </a:avLst>
           </a:prstGeom>
           <a:solidFill>
@@ -1349,7 +1349,7 @@
         </p:nvSpPr>
         <p:spPr>
           <a:xfrm>
-            <a:off x="694944" y="3840480"/>
+            <a:off x="694944" y="3429000"/>
             <a:ext cx="2743200" cy="219456"/>
           </a:xfrm>
           <a:prstGeom prst="rect">
@@ -1388,8 +1388,8 @@
         </p:nvSpPr>
         <p:spPr>
           <a:xfrm>
-            <a:off x="694944" y="4169664"/>
-            <a:ext cx="6336792" cy="2331720"/>
+            <a:off x="694944" y="3739896"/>
+            <a:ext cx="6336792" cy="1106424"/>
           </a:xfrm>
           <a:prstGeom prst="rect">
             <a:avLst/>
@@ -1406,23 +1406,23 @@
                 <a:spcPct val="93000"/>
               </a:lnSpc>
               <a:spcAft>
-                <a:spcPts val="1000"/>
+                <a:spcPts val="600"/>
               </a:spcAft>
               <a:buSzPct val="100000"/>
               <a:buChar char="•"/>
             </a:pPr>
             <a:r>
-              <a:rPr lang="en-US" sz="1050" dirty="0">
-                <a:solidFill>
-                  <a:srgbClr val="1F2328"/>
-                </a:solidFill>
-                <a:latin typeface="Arial" pitchFamily="34" charset="0"/>
-                <a:ea typeface="Arial" pitchFamily="34" charset="-122"/>
-                <a:cs typeface="Arial" pitchFamily="34" charset="-120"/>
-              </a:rPr>
-              <a:t>Opportunities are identified mainly through workshops, which take time to organise and depend heavily on the knowledge of those who attend.</a:t>
-            </a:r>
-            <a:endParaRPr lang="en-US" sz="1050" dirty="0"/>
+              <a:rPr lang="en-US" sz="1000" dirty="0">
+                <a:solidFill>
+                  <a:srgbClr val="1F2328"/>
+                </a:solidFill>
+                <a:latin typeface="Arial" pitchFamily="34" charset="0"/>
+                <a:ea typeface="Arial" pitchFamily="34" charset="-122"/>
+                <a:cs typeface="Arial" pitchFamily="34" charset="-120"/>
+              </a:rPr>
+              <a:t>Opportunities are identified mainly through workshops, which take time to organise and depend on who attends.</a:t>
+            </a:r>
+            <a:endParaRPr lang="en-US" sz="1000" dirty="0"/>
           </a:p>
           <a:p>
             <a:pPr marL="342900" indent="-342900">
@@ -1430,13 +1430,13 @@
                 <a:spcPct val="93000"/>
               </a:lnSpc>
               <a:spcAft>
-                <a:spcPts val="1000"/>
+                <a:spcPts val="600"/>
               </a:spcAft>
               <a:buSzPct val="100000"/>
               <a:buChar char="•"/>
             </a:pPr>
             <a:r>
-              <a:rPr lang="en-US" sz="1050" dirty="0">
+              <a:rPr lang="en-US" sz="1000" dirty="0">
                 <a:solidFill>
                   <a:srgbClr val="1F2328"/>
                 </a:solidFill>
@@ -1446,7 +1446,7 @@
               </a:rPr>
               <a:t>Ideas are often high level, with limited detail on materials, processes, specifications or technical constraints.</a:t>
             </a:r>
-            <a:endParaRPr lang="en-US" sz="1050" dirty="0"/>
+            <a:endParaRPr lang="en-US" sz="1000" dirty="0"/>
           </a:p>
           <a:p>
             <a:pPr marL="342900" indent="-342900">
@@ -1454,13 +1454,13 @@
                 <a:spcPct val="93000"/>
               </a:lnSpc>
               <a:spcAft>
-                <a:spcPts val="1000"/>
+                <a:spcPts val="600"/>
               </a:spcAft>
               <a:buSzPct val="100000"/>
               <a:buChar char="•"/>
             </a:pPr>
             <a:r>
-              <a:rPr lang="en-US" sz="1050" dirty="0">
+              <a:rPr lang="en-US" sz="1000" dirty="0">
                 <a:solidFill>
                   <a:srgbClr val="1F2328"/>
                 </a:solidFill>
@@ -1470,7 +1470,7 @@
               </a:rPr>
               <a:t>Savings can only be confirmed after manual analysis, costing and data review.</a:t>
             </a:r>
-            <a:endParaRPr lang="en-US" sz="1050" dirty="0"/>
+            <a:endParaRPr lang="en-US" sz="1000" dirty="0"/>
           </a:p>
           <a:p>
             <a:pPr marL="342900" indent="-342900">
@@ -1478,47 +1478,174 @@
                 <a:spcPct val="93000"/>
               </a:lnSpc>
               <a:spcAft>
-                <a:spcPts val="1000"/>
+                <a:spcPts val="600"/>
               </a:spcAft>
               <a:buSzPct val="100000"/>
               <a:buChar char="•"/>
             </a:pPr>
             <a:r>
-              <a:rPr lang="en-US" sz="1050" dirty="0">
-                <a:solidFill>
-                  <a:srgbClr val="1F2328"/>
-                </a:solidFill>
-                <a:latin typeface="Arial" pitchFamily="34" charset="0"/>
-                <a:ea typeface="Arial" pitchFamily="34" charset="-122"/>
-                <a:cs typeface="Arial" pitchFamily="34" charset="-120"/>
-              </a:rPr>
-              <a:t>Technical review, costing and prioritisation are carried out separately, which slows decision making.</a:t>
-            </a:r>
-            <a:endParaRPr lang="en-US" sz="1050" dirty="0"/>
-          </a:p>
+              <a:rPr lang="en-US" sz="1000" dirty="0">
+                <a:solidFill>
+                  <a:srgbClr val="1F2328"/>
+                </a:solidFill>
+                <a:latin typeface="Arial" pitchFamily="34" charset="0"/>
+                <a:ea typeface="Arial" pitchFamily="34" charset="-122"/>
+                <a:cs typeface="Arial" pitchFamily="34" charset="-120"/>
+              </a:rPr>
+              <a:t>Engineers spend significant time collecting and interpreting data, and the process is difficult to scale.</a:t>
+            </a:r>
+            <a:endParaRPr lang="en-US" sz="1000" dirty="0"/>
+          </a:p>
+        </p:txBody>
+      </p:sp>
+      <p:sp>
+        <p:nvSpPr>
+          <p:cNvPr id="12" name="Shape 10"/>
+          <p:cNvSpPr/>
+          <p:nvPr/>
+        </p:nvSpPr>
+        <p:spPr>
+          <a:xfrm>
+            <a:off x="457200" y="5001768"/>
+            <a:ext cx="6812280" cy="1627632"/>
+          </a:xfrm>
+          <a:prstGeom prst="roundRect">
+            <a:avLst>
+              <a:gd name="adj" fmla="val 5056"/>
+            </a:avLst>
+          </a:prstGeom>
+          <a:solidFill>
+            <a:srgbClr val="FBFCFD"/>
+          </a:solidFill>
+          <a:ln w="9525">
+            <a:solidFill>
+              <a:srgbClr val="C9D1D9"/>
+            </a:solidFill>
+            <a:prstDash val="solid"/>
+          </a:ln>
+        </p:spPr>
+      </p:sp>
+      <p:sp>
+        <p:nvSpPr>
+          <p:cNvPr id="13" name="Text 11"/>
+          <p:cNvSpPr txBox="1"/>
+          <p:nvPr/>
+        </p:nvSpPr>
+        <p:spPr>
+          <a:xfrm>
+            <a:off x="694944" y="5102352"/>
+            <a:ext cx="3291840" cy="219456"/>
+          </a:xfrm>
+          <a:prstGeom prst="rect">
+            <a:avLst/>
+          </a:prstGeom>
+          <a:noFill/>
+          <a:ln/>
+        </p:spPr>
+        <p:txBody>
+          <a:bodyPr wrap="square" lIns="0" tIns="0" rIns="0" bIns="0" rtlCol="0" anchor="t"/>
+          <a:lstStyle/>
+          <a:p>
+            <a:pPr indent="0" marL="0">
+              <a:buNone/>
+            </a:pPr>
+            <a:r>
+              <a:rPr lang="en-US" sz="1200" b="1" dirty="0">
+                <a:solidFill>
+                  <a:srgbClr val="1F2328"/>
+                </a:solidFill>
+                <a:latin typeface="Arial" pitchFamily="34" charset="0"/>
+                <a:ea typeface="Arial" pitchFamily="34" charset="-122"/>
+                <a:cs typeface="Arial" pitchFamily="34" charset="-120"/>
+              </a:rPr>
+              <a:t>Proposed Solution / Model</a:t>
+            </a:r>
+            <a:endParaRPr lang="en-US" sz="1200" dirty="0"/>
+          </a:p>
+        </p:txBody>
+      </p:sp>
+      <p:sp>
+        <p:nvSpPr>
+          <p:cNvPr id="14" name="Text 12"/>
+          <p:cNvSpPr txBox="1"/>
+          <p:nvPr/>
+        </p:nvSpPr>
+        <p:spPr>
+          <a:xfrm>
+            <a:off x="5669280" y="5120640"/>
+            <a:ext cx="1371600" cy="201168"/>
+          </a:xfrm>
+          <a:prstGeom prst="rect">
+            <a:avLst/>
+          </a:prstGeom>
+          <a:noFill/>
+          <a:ln/>
+        </p:spPr>
+        <p:txBody>
+          <a:bodyPr wrap="square" lIns="0" tIns="0" rIns="0" bIns="0" rtlCol="0" anchor="t"/>
+          <a:lstStyle/>
+          <a:p>
+            <a:pPr algn="r" indent="0" marL="0">
+              <a:buNone/>
+            </a:pPr>
+            <a:r>
+              <a:rPr lang="en-US" sz="900" i="1" dirty="0">
+                <a:solidFill>
+                  <a:srgbClr val="5B6570"/>
+                </a:solidFill>
+                <a:latin typeface="Arial" pitchFamily="34" charset="0"/>
+                <a:ea typeface="Arial" pitchFamily="34" charset="-122"/>
+                <a:cs typeface="Arial" pitchFamily="34" charset="-120"/>
+              </a:rPr>
+              <a:t>Detail on slide 2</a:t>
+            </a:r>
+            <a:endParaRPr lang="en-US" sz="900" dirty="0"/>
+          </a:p>
+        </p:txBody>
+      </p:sp>
+      <p:sp>
+        <p:nvSpPr>
+          <p:cNvPr id="15" name="Text 13"/>
+          <p:cNvSpPr txBox="1"/>
+          <p:nvPr/>
+        </p:nvSpPr>
+        <p:spPr>
+          <a:xfrm>
+            <a:off x="694944" y="5413248"/>
+            <a:ext cx="6336792" cy="1133856"/>
+          </a:xfrm>
+          <a:prstGeom prst="rect">
+            <a:avLst/>
+          </a:prstGeom>
+          <a:noFill/>
+          <a:ln/>
+        </p:spPr>
+        <p:txBody>
+          <a:bodyPr wrap="square" lIns="0" tIns="0" rIns="0" bIns="0" rtlCol="0" anchor="t"/>
+          <a:lstStyle/>
           <a:p>
             <a:pPr marL="342900" indent="-342900">
               <a:lnSpc>
                 <a:spcPct val="93000"/>
               </a:lnSpc>
               <a:spcAft>
-                <a:spcPts val="1000"/>
+                <a:spcPts val="900"/>
               </a:spcAft>
               <a:buSzPct val="100000"/>
               <a:buChar char="•"/>
             </a:pPr>
             <a:r>
-              <a:rPr lang="en-US" sz="1050" dirty="0">
-                <a:solidFill>
-                  <a:srgbClr val="1F2328"/>
-                </a:solidFill>
-                <a:latin typeface="Arial" pitchFamily="34" charset="0"/>
-                <a:ea typeface="Arial" pitchFamily="34" charset="-122"/>
-                <a:cs typeface="Arial" pitchFamily="34" charset="-120"/>
-              </a:rPr>
-              <a:t>The quality of ideas varies with individual experience, and only a small portion of parts can be reviewed.</a:t>
-            </a:r>
-            <a:endParaRPr lang="en-US" sz="1050" dirty="0"/>
+              <a:rPr lang="en-US" sz="1000" dirty="0">
+                <a:solidFill>
+                  <a:srgbClr val="1F2328"/>
+                </a:solidFill>
+                <a:latin typeface="Arial" pitchFamily="34" charset="0"/>
+                <a:ea typeface="Arial" pitchFamily="34" charset="-122"/>
+                <a:cs typeface="Arial" pitchFamily="34" charset="-120"/>
+              </a:rPr>
+              <a:t>Upload CAD models, drawings, BOMs and cost data into the tool.</a:t>
+            </a:r>
+            <a:endParaRPr lang="en-US" sz="1000" dirty="0"/>
           </a:p>
           <a:p>
             <a:pPr marL="342900" indent="-342900">
@@ -1526,23 +1653,23 @@
                 <a:spcPct val="93000"/>
               </a:lnSpc>
               <a:spcAft>
-                <a:spcPts val="1000"/>
+                <a:spcPts val="900"/>
               </a:spcAft>
               <a:buSzPct val="100000"/>
               <a:buChar char="•"/>
             </a:pPr>
             <a:r>
-              <a:rPr lang="en-US" sz="1050" dirty="0">
-                <a:solidFill>
-                  <a:srgbClr val="1F2328"/>
-                </a:solidFill>
-                <a:latin typeface="Arial" pitchFamily="34" charset="0"/>
-                <a:ea typeface="Arial" pitchFamily="34" charset="-122"/>
-                <a:cs typeface="Arial" pitchFamily="34" charset="-120"/>
-              </a:rPr>
-              <a:t>Engineers spend significant time collecting and interpreting data instead of implementing improvements.</a:t>
-            </a:r>
-            <a:endParaRPr lang="en-US" sz="1050" dirty="0"/>
+              <a:rPr lang="en-US" sz="1000" dirty="0">
+                <a:solidFill>
+                  <a:srgbClr val="1F2328"/>
+                </a:solidFill>
+                <a:latin typeface="Arial" pitchFamily="34" charset="0"/>
+                <a:ea typeface="Arial" pitchFamily="34" charset="-122"/>
+                <a:cs typeface="Arial" pitchFamily="34" charset="-120"/>
+              </a:rPr>
+              <a:t>The design, materials, processes and costs are reviewed automatically, and detailed ideas are generated — each with the change, the saving and the rationale.</a:t>
+            </a:r>
+            <a:endParaRPr lang="en-US" sz="1000" dirty="0"/>
           </a:p>
           <a:p>
             <a:pPr marL="342900" indent="-342900">
@@ -1550,29 +1677,53 @@
                 <a:spcPct val="93000"/>
               </a:lnSpc>
               <a:spcAft>
-                <a:spcPts val="1000"/>
+                <a:spcPts val="900"/>
               </a:spcAft>
               <a:buSzPct val="100000"/>
               <a:buChar char="•"/>
             </a:pPr>
             <a:r>
-              <a:rPr lang="en-US" sz="1050" dirty="0">
-                <a:solidFill>
-                  <a:srgbClr val="1F2328"/>
-                </a:solidFill>
-                <a:latin typeface="Arial" pitchFamily="34" charset="0"/>
-                <a:ea typeface="Arial" pitchFamily="34" charset="-122"/>
-                <a:cs typeface="Arial" pitchFamily="34" charset="-120"/>
-              </a:rPr>
-              <a:t>The process is resource-intensive, time-consuming and difficult to scale across programmes and teams.</a:t>
-            </a:r>
-            <a:endParaRPr lang="en-US" sz="1050" dirty="0"/>
+              <a:rPr lang="en-US" sz="1000" dirty="0">
+                <a:solidFill>
+                  <a:srgbClr val="1F2328"/>
+                </a:solidFill>
+                <a:latin typeface="Arial" pitchFamily="34" charset="0"/>
+                <a:ea typeface="Arial" pitchFamily="34" charset="-122"/>
+                <a:cs typeface="Arial" pitchFamily="34" charset="-120"/>
+              </a:rPr>
+              <a:t>Thousands of parts and assemblies can be assessed, consistently, using the same approach every time.</a:t>
+            </a:r>
+            <a:endParaRPr lang="en-US" sz="1000" dirty="0"/>
+          </a:p>
+          <a:p>
+            <a:pPr marL="342900" indent="-342900">
+              <a:lnSpc>
+                <a:spcPct val="93000"/>
+              </a:lnSpc>
+              <a:spcAft>
+                <a:spcPts val="900"/>
+              </a:spcAft>
+              <a:buSzPct val="100000"/>
+              <a:buChar char="•"/>
+            </a:pPr>
+            <a:r>
+              <a:rPr lang="en-US" sz="1000" dirty="0">
+                <a:solidFill>
+                  <a:srgbClr val="1F2328"/>
+                </a:solidFill>
+                <a:latin typeface="Arial" pitchFamily="34" charset="0"/>
+                <a:ea typeface="Arial" pitchFamily="34" charset="-122"/>
+                <a:cs typeface="Arial" pitchFamily="34" charset="-120"/>
+              </a:rPr>
+              <a:t>Tools built inside BrainSpark: Prism, Innovation Studio, TRIZ Studio and DFM / DFA.</a:t>
+            </a:r>
+            <a:endParaRPr lang="en-US" sz="1000" dirty="0"/>
           </a:p>
         </p:txBody>
       </p:sp>
       <p:sp>
         <p:nvSpPr>
-          <p:cNvPr id="12" name="Shape 10"/>
+          <p:cNvPr id="16" name="Shape 14"/>
           <p:cNvSpPr/>
           <p:nvPr/>
         </p:nvSpPr>
@@ -1599,7 +1750,7 @@
       </p:sp>
       <p:sp>
         <p:nvSpPr>
-          <p:cNvPr id="13" name="Text 11"/>
+          <p:cNvPr id="17" name="Text 15"/>
           <p:cNvSpPr txBox="1"/>
           <p:nvPr/>
         </p:nvSpPr>
@@ -1638,7 +1789,7 @@
       </p:sp>
       <p:sp>
         <p:nvSpPr>
-          <p:cNvPr id="14" name="Text 12"/>
+          <p:cNvPr id="18" name="Text 16"/>
           <p:cNvSpPr txBox="1"/>
           <p:nvPr/>
         </p:nvSpPr>
@@ -1749,7 +1900,7 @@
       </p:sp>
       <p:sp>
         <p:nvSpPr>
-          <p:cNvPr id="15" name="Shape 13"/>
+          <p:cNvPr id="19" name="Shape 17"/>
           <p:cNvSpPr/>
           <p:nvPr/>
         </p:nvSpPr>
@@ -1776,7 +1927,7 @@
       </p:sp>
       <p:sp>
         <p:nvSpPr>
-          <p:cNvPr id="16" name="Text 14"/>
+          <p:cNvPr id="20" name="Text 18"/>
           <p:cNvSpPr txBox="1"/>
           <p:nvPr/>
         </p:nvSpPr>
@@ -1815,7 +1966,7 @@
       </p:sp>
       <p:sp>
         <p:nvSpPr>
-          <p:cNvPr id="17" name="Shape 15"/>
+          <p:cNvPr id="21" name="Shape 19"/>
           <p:cNvSpPr/>
           <p:nvPr/>
         </p:nvSpPr>
@@ -1842,7 +1993,7 @@
       </p:sp>
       <p:sp>
         <p:nvSpPr>
-          <p:cNvPr id="18" name="Text 16"/>
+          <p:cNvPr id="22" name="Text 20"/>
           <p:cNvSpPr txBox="1"/>
           <p:nvPr/>
         </p:nvSpPr>
@@ -1881,7 +2032,7 @@
       </p:sp>
       <p:sp>
         <p:nvSpPr>
-          <p:cNvPr id="19" name="Text 17"/>
+          <p:cNvPr id="23" name="Text 21"/>
           <p:cNvSpPr txBox="1"/>
           <p:nvPr/>
         </p:nvSpPr>

</xml_diff>